<commit_message>
Pivot to all-software stand: web games, poster refresh, updated TODO.
Add self-contained browser games in software/web/, refactor poster for five games with arraxis.com QR and A3 sign, and record the Arraxis deploy plan in NOTES and TODO.

Co-authored-by: Cursor <cursoragent@cursor.com>
</commit_message>
<xml_diff>
--- a/poster/Hack_the_Quantum_Poster_DE.pptx
+++ b/poster/Hack_the_Quantum_Poster_DE.pptx
@@ -1141,253 +1141,6 @@
       </p:grpSpPr>
       <p:sp>
         <p:nvSpPr>
-          <p:cNvPr id="4" name="Textfeld">
-            <a:extLst>
-              <a:ext uri="{FF2B5EF4-FFF2-40B4-BE49-F238E27FC236}">
-                <a16:creationId xmlns:a16="http://schemas.microsoft.com/office/drawing/2014/main" id="{2D58A933-1368-BDA9-D738-82CD528BF039}"/>
-              </a:ext>
-            </a:extLst>
-          </p:cNvPr>
-          <p:cNvSpPr txBox="1">
-            <a:spLocks noGrp="1" noRot="1" noMove="1" noResize="1" noEditPoints="1" noAdjustHandles="1" noChangeArrowheads="1" noChangeShapeType="1"/>
-          </p:cNvSpPr>
-          <p:nvPr/>
-        </p:nvSpPr>
-        <p:spPr>
-          <a:xfrm>
-            <a:off x="1295400" y="11091864"/>
-            <a:ext cx="9052560" cy="17907750"/>
-          </a:xfrm>
-          <a:prstGeom prst="rect">
-            <a:avLst/>
-          </a:prstGeom>
-          <a:noFill/>
-        </p:spPr>
-        <p:txBody>
-          <a:bodyPr wrap="square" numCol="1" rtlCol="0">
-            <a:noAutofit/>
-          </a:bodyPr>
-          <a:lstStyle/>
-          <a:p>
-            <a:pPr>
-              <a:lnSpc>
-                <a:spcPts val="4000"/>
-              </a:lnSpc>
-              <a:spcAft>
-                <a:spcPts val="600"/>
-              </a:spcAft>
-            </a:pPr>
-            <a:r>
-              <a:rPr lang="de-DE" sz="3600" b="1" dirty="0">
-                <a:solidFill>
-                  <a:srgbClr val="05366C"/>
-                </a:solidFill>
-                <a:latin typeface="Arial" panose="020B0604020202020204" pitchFamily="34" charset="0"/>
-                <a:cs typeface="Arial" panose="020B0604020202020204" pitchFamily="34" charset="0"/>
-              </a:rPr>
-              <a:t xml:space="preserve">So geht’s</a:t>
-            </a:r>
-          </a:p>
-          <a:p>
-            <a:pPr>
-              <a:lnSpc>
-                <a:spcPts val="4000"/>
-              </a:lnSpc>
-            </a:pPr>
-            <a:r>
-              <a:rPr lang="de-DE" sz="3600" dirty="0">
-                <a:latin typeface="Arial" panose="020B0604020202020204" pitchFamily="34" charset="0"/>
-                <a:cs typeface="Arial" panose="020B0604020202020204" pitchFamily="34" charset="0"/>
-              </a:rPr>
-              <a:t xml:space="preserve">1.  Mach Licht: halte deine Taschenlampe oder Hand über den Lichtsensor.</a:t>
-            </a:r>
-          </a:p>
-          <a:p>
-            <a:pPr>
-              <a:lnSpc>
-                <a:spcPts val="4000"/>
-              </a:lnSpc>
-            </a:pPr>
-            <a:r>
-              <a:rPr lang="de-DE" sz="3600" dirty="0">
-                <a:latin typeface="Arial" panose="020B0604020202020204" pitchFamily="34" charset="0"/>
-                <a:cs typeface="Arial" panose="020B0604020202020204" pitchFamily="34" charset="0"/>
-              </a:rPr>
-              <a:t xml:space="preserve">2.  Wähle dein Ziel: eine 0 oder eine 1.</a:t>
-            </a:r>
-          </a:p>
-          <a:p>
-            <a:pPr>
-              <a:lnSpc>
-                <a:spcPts val="4000"/>
-              </a:lnSpc>
-            </a:pPr>
-            <a:r>
-              <a:rPr lang="de-DE" sz="3600" dirty="0">
-                <a:latin typeface="Arial" panose="020B0604020202020204" pitchFamily="34" charset="0"/>
-                <a:cs typeface="Arial" panose="020B0604020202020204" pitchFamily="34" charset="0"/>
-              </a:rPr>
-              <a:t xml:space="preserve">3.  Spiele drei Runden – und versuche, das Ergebnis zu steuern.</a:t>
-            </a:r>
-          </a:p>
-          <a:p>
-            <a:pPr>
-              <a:lnSpc>
-                <a:spcPts val="1800"/>
-              </a:lnSpc>
-            </a:pPr>
-            <a:endParaRPr lang="de-DE" sz="3600"/>
-          </a:p>
-          <a:p>
-            <a:pPr>
-              <a:lnSpc>
-                <a:spcPts val="4000"/>
-              </a:lnSpc>
-              <a:spcAft>
-                <a:spcPts val="600"/>
-              </a:spcAft>
-            </a:pPr>
-            <a:r>
-              <a:rPr lang="de-DE" sz="3600" b="1" dirty="0">
-                <a:solidFill>
-                  <a:srgbClr val="05366C"/>
-                </a:solidFill>
-                <a:latin typeface="Arial" panose="020B0604020202020204" pitchFamily="34" charset="0"/>
-                <a:cs typeface="Arial" panose="020B0604020202020204" pitchFamily="34" charset="0"/>
-              </a:rPr>
-              <a:t xml:space="preserve">Warum ist das spannend?</a:t>
-            </a:r>
-          </a:p>
-          <a:p>
-            <a:pPr>
-              <a:lnSpc>
-                <a:spcPts val="4000"/>
-              </a:lnSpc>
-            </a:pPr>
-            <a:r>
-              <a:rPr lang="de-DE" sz="3600" dirty="0">
-                <a:latin typeface="Arial" panose="020B0604020202020204" pitchFamily="34" charset="0"/>
-                <a:cs typeface="Arial" panose="020B0604020202020204" pitchFamily="34" charset="0"/>
-              </a:rPr>
-              <a:t xml:space="preserve">Aus Licht wird digitale Information – Nullen und Einsen.</a:t>
-            </a:r>
-          </a:p>
-          <a:p>
-            <a:pPr>
-              <a:lnSpc>
-                <a:spcPts val="4000"/>
-              </a:lnSpc>
-            </a:pPr>
-            <a:r>
-              <a:rPr lang="de-DE" sz="3600" dirty="0">
-                <a:latin typeface="Arial" panose="020B0604020202020204" pitchFamily="34" charset="0"/>
-                <a:cs typeface="Arial" panose="020B0604020202020204" pitchFamily="34" charset="0"/>
-              </a:rPr>
-              <a:t xml:space="preserve">Manche Dinge kann man steuern. Manche sind grundsätzlich nicht vorhersagbar.</a:t>
-            </a:r>
-          </a:p>
-          <a:p>
-            <a:pPr>
-              <a:lnSpc>
-                <a:spcPts val="4000"/>
-              </a:lnSpc>
-            </a:pPr>
-            <a:r>
-              <a:rPr lang="de-DE" sz="3600" dirty="0">
-                <a:latin typeface="Arial" panose="020B0604020202020204" pitchFamily="34" charset="0"/>
-                <a:cs typeface="Arial" panose="020B0604020202020204" pitchFamily="34" charset="0"/>
-              </a:rPr>
-              <a:t xml:space="preserve">Genau dieser Zufall ist wichtig für künstliche Intelligenz, Sicherheit im Internet und Quantentechnologie – die Technik der Zukunft.</a:t>
-            </a:r>
-          </a:p>
-          <a:p>
-            <a:pPr>
-              <a:lnSpc>
-                <a:spcPts val="1800"/>
-              </a:lnSpc>
-            </a:pPr>
-            <a:endParaRPr lang="de-DE" sz="3600"/>
-          </a:p>
-          <a:p>
-            <a:pPr>
-              <a:lnSpc>
-                <a:spcPts val="4000"/>
-              </a:lnSpc>
-              <a:spcAft>
-                <a:spcPts val="600"/>
-              </a:spcAft>
-            </a:pPr>
-            <a:r>
-              <a:rPr lang="de-DE" sz="3600" b="1" dirty="0">
-                <a:solidFill>
-                  <a:srgbClr val="05366C"/>
-                </a:solidFill>
-                <a:latin typeface="Arial" panose="020B0604020202020204" pitchFamily="34" charset="0"/>
-                <a:cs typeface="Arial" panose="020B0604020202020204" pitchFamily="34" charset="0"/>
-              </a:rPr>
-              <a:t xml:space="preserve">Mehr zum Mitmachen</a:t>
-            </a:r>
-          </a:p>
-          <a:p>
-            <a:pPr>
-              <a:lnSpc>
-                <a:spcPts val="4000"/>
-              </a:lnSpc>
-            </a:pPr>
-            <a:r>
-              <a:rPr lang="de-DE" sz="3600" dirty="0">
-                <a:latin typeface="Arial" panose="020B0604020202020204" pitchFamily="34" charset="0"/>
-                <a:cs typeface="Arial" panose="020B0604020202020204" pitchFamily="34" charset="0"/>
-              </a:rPr>
-              <a:t xml:space="preserve">Probiere am Bildschirm auch unsere Quanten-Spiele aus, zum Beispiel Quanten-Tic-Tac-Toe.</a:t>
-            </a:r>
-          </a:p>
-          <a:p>
-            <a:pPr>
-              <a:lnSpc>
-                <a:spcPts val="1800"/>
-              </a:lnSpc>
-            </a:pPr>
-            <a:endParaRPr lang="de-DE" sz="3600"/>
-          </a:p>
-          <a:p>
-            <a:pPr>
-              <a:lnSpc>
-                <a:spcPts val="4000"/>
-              </a:lnSpc>
-              <a:spcAft>
-                <a:spcPts val="600"/>
-              </a:spcAft>
-            </a:pPr>
-            <a:r>
-              <a:rPr lang="de-DE" sz="3600" b="1" dirty="0">
-                <a:solidFill>
-                  <a:srgbClr val="05366C"/>
-                </a:solidFill>
-                <a:latin typeface="Arial" panose="020B0604020202020204" pitchFamily="34" charset="0"/>
-                <a:cs typeface="Arial" panose="020B0604020202020204" pitchFamily="34" charset="0"/>
-              </a:rPr>
-              <a:t xml:space="preserve">Kontakt</a:t>
-            </a:r>
-          </a:p>
-          <a:p>
-            <a:pPr>
-              <a:lnSpc>
-                <a:spcPts val="4000"/>
-              </a:lnSpc>
-            </a:pPr>
-            <a:r>
-              <a:rPr lang="de-DE" sz="3600" dirty="0">
-                <a:latin typeface="Arial" panose="020B0604020202020204" pitchFamily="34" charset="0"/>
-                <a:cs typeface="Arial" panose="020B0604020202020204" pitchFamily="34" charset="0"/>
-              </a:rPr>
-              <a:t xml:space="preserve">Pavel Sulimov &amp; Claude Lehmann · Institut InIT · ZHAW School of Engineering</a:t>
-            </a:r>
-          </a:p>
-        </p:txBody>
-      </p:sp>
-      <p:sp>
-        <p:nvSpPr>
           <p:cNvPr id="17" name="Folientitel">
             <a:extLst>
               <a:ext uri="{FF2B5EF4-FFF2-40B4-BE49-F238E27FC236}">
@@ -1500,7 +1253,7 @@
                 <a:latin typeface="Arial" panose="020B0604020202020204" pitchFamily="34" charset="0"/>
                 <a:cs typeface="Arial" panose="020B0604020202020204" pitchFamily="34" charset="0"/>
               </a:rPr>
-              <a:t>Institut für Informatik</a:t>
+              <a:t>Quantum Lab</a:t>
             </a:r>
             <a:endParaRPr lang="en-US" sz="4000" dirty="0">
               <a:solidFill>
@@ -1679,157 +1432,6 @@
           </a:p>
         </p:txBody>
       </p:sp>
-      <p:grpSp>
-        <p:nvGrpSpPr>
-          <p:cNvPr id="8" name="Kreis mit QR-Code" descr="Kreis mit einem QR Code und dem Text „Mehr erfahren!“">
-            <a:extLst>
-              <a:ext uri="{FF2B5EF4-FFF2-40B4-BE49-F238E27FC236}">
-                <a16:creationId xmlns:a16="http://schemas.microsoft.com/office/drawing/2014/main" id="{18FD1BFD-D9E1-9E6B-3FCE-D8CA30704C6D}"/>
-              </a:ext>
-            </a:extLst>
-          </p:cNvPr>
-          <p:cNvGrpSpPr/>
-          <p:nvPr/>
-        </p:nvGrpSpPr>
-        <p:grpSpPr>
-          <a:xfrm>
-            <a:off x="14792292" y="22022813"/>
-            <a:ext cx="3801708" cy="3879738"/>
-            <a:chOff x="14792292" y="22480013"/>
-            <a:chExt cx="3801708" cy="3879738"/>
-          </a:xfrm>
-        </p:grpSpPr>
-        <p:sp>
-          <p:nvSpPr>
-            <p:cNvPr id="19" name="Kreis">
-              <a:extLst>
-                <a:ext uri="{FF2B5EF4-FFF2-40B4-BE49-F238E27FC236}">
-                  <a16:creationId xmlns:a16="http://schemas.microsoft.com/office/drawing/2014/main" id="{D93DCC13-F65B-A35E-C39E-875277567DF4}"/>
-                </a:ext>
-                <a:ext uri="{C183D7F6-B498-43B3-948B-1728B52AA6E4}">
-                  <adec:decorative xmlns:adec="http://schemas.microsoft.com/office/drawing/2017/decorative" val="1"/>
-                </a:ext>
-              </a:extLst>
-            </p:cNvPr>
-            <p:cNvSpPr>
-              <a:spLocks/>
-            </p:cNvSpPr>
-            <p:nvPr/>
-          </p:nvSpPr>
-          <p:spPr>
-            <a:xfrm>
-              <a:off x="14792400" y="22558151"/>
-              <a:ext cx="3801600" cy="3801600"/>
-            </a:xfrm>
-            <a:prstGeom prst="ellipse">
-              <a:avLst/>
-            </a:prstGeom>
-            <a:solidFill>
-              <a:srgbClr val="4DA18E"/>
-            </a:solidFill>
-            <a:ln>
-              <a:noFill/>
-            </a:ln>
-          </p:spPr>
-          <p:style>
-            <a:lnRef idx="2">
-              <a:schemeClr val="accent1">
-                <a:shade val="15000"/>
-              </a:schemeClr>
-            </a:lnRef>
-            <a:fillRef idx="1">
-              <a:schemeClr val="accent1"/>
-            </a:fillRef>
-            <a:effectRef idx="0">
-              <a:schemeClr val="accent1"/>
-            </a:effectRef>
-            <a:fontRef idx="minor">
-              <a:schemeClr val="lt1"/>
-            </a:fontRef>
-          </p:style>
-          <p:txBody>
-            <a:bodyPr rtlCol="0" anchor="ctr"/>
-            <a:lstStyle/>
-            <a:p>
-              <a:pPr algn="ctr"/>
-              <a:endParaRPr lang="de-ES">
-                <a:ln>
-                  <a:solidFill>
-                    <a:srgbClr val="8FC45F"/>
-                  </a:solidFill>
-                </a:ln>
-                <a:solidFill>
-                  <a:srgbClr val="A3D045"/>
-                </a:solidFill>
-              </a:endParaRPr>
-            </a:p>
-          </p:txBody>
-        </p:sp>
-        <p:pic>
-          <p:nvPicPr>
-            <p:cNvPr id="12" name="Mehr erfahren!" descr="Mehr erfahren!">
-              <a:extLst>
-                <a:ext uri="{FF2B5EF4-FFF2-40B4-BE49-F238E27FC236}">
-                  <a16:creationId xmlns:a16="http://schemas.microsoft.com/office/drawing/2014/main" id="{7DF056DB-EA44-3551-4504-B78726E41F79}"/>
-                </a:ext>
-                <a:ext uri="{C183D7F6-B498-43B3-948B-1728B52AA6E4}">
-                  <adec:decorative xmlns:adec="http://schemas.microsoft.com/office/drawing/2017/decorative" val="0"/>
-                </a:ext>
-              </a:extLst>
-            </p:cNvPr>
-            <p:cNvPicPr>
-              <a:picLocks noChangeAspect="1"/>
-            </p:cNvPicPr>
-            <p:nvPr/>
-          </p:nvPicPr>
-          <p:blipFill>
-            <a:blip r:embed="rId3"/>
-            <a:srcRect/>
-            <a:stretch/>
-          </p:blipFill>
-          <p:spPr>
-            <a:xfrm>
-              <a:off x="14792292" y="22480013"/>
-              <a:ext cx="3797300" cy="3797300"/>
-            </a:xfrm>
-            <a:prstGeom prst="rect">
-              <a:avLst/>
-            </a:prstGeom>
-          </p:spPr>
-        </p:pic>
-        <p:pic>
-          <p:nvPicPr>
-            <p:cNvPr id="11" name="Platzhalter QR-Code" descr="QR Code">
-              <a:extLst>
-                <a:ext uri="{FF2B5EF4-FFF2-40B4-BE49-F238E27FC236}">
-                  <a16:creationId xmlns:a16="http://schemas.microsoft.com/office/drawing/2014/main" id="{D84D71BB-BA10-0E5C-C620-0F993CC71886}"/>
-                </a:ext>
-                <a:ext uri="{C183D7F6-B498-43B3-948B-1728B52AA6E4}">
-                  <adec:decorative xmlns:adec="http://schemas.microsoft.com/office/drawing/2017/decorative" val="0"/>
-                </a:ext>
-              </a:extLst>
-            </p:cNvPr>
-            <p:cNvPicPr>
-              <a:picLocks noChangeAspect="1"/>
-            </p:cNvPicPr>
-            <p:nvPr/>
-          </p:nvPicPr>
-          <p:blipFill>
-            <a:blip r:embed="rId4"/>
-            <a:srcRect/>
-            <a:stretch/>
-          </p:blipFill>
-          <p:spPr>
-            <a:xfrm>
-              <a:off x="15759642" y="23448947"/>
-              <a:ext cx="1866900" cy="1790700"/>
-            </a:xfrm>
-            <a:prstGeom prst="rect">
-              <a:avLst/>
-            </a:prstGeom>
-          </p:spPr>
-        </p:pic>
-      </p:grpSp>
       <p:sp>
         <p:nvSpPr>
           <p:cNvPr id="23" name="TextBox 22"/>
@@ -1838,8 +1440,8 @@
         </p:nvSpPr>
         <p:spPr>
           <a:xfrm>
-            <a:off x="10972800" y="11091672"/>
-            <a:ext cx="8778240" cy="1097280"/>
+            <a:off x="1280160" y="11018520"/>
+            <a:ext cx="8778240" cy="731520"/>
           </a:xfrm>
           <a:prstGeom prst="rect">
             <a:avLst/>
@@ -1847,45 +1449,45 @@
           <a:noFill/>
         </p:spPr>
         <p:txBody>
-          <a:bodyPr wrap="square" anchor="t" lIns="109728" rIns="109728" tIns="109728" bIns="109728">
+          <a:bodyPr wrap="square" anchor="t" lIns="54864" rIns="54864" tIns="54864" bIns="54864">
             <a:spAutoFit/>
           </a:bodyPr>
           <a:lstStyle/>
           <a:p>
-            <a:pPr>
-              <a:lnSpc>
-                <a:spcPts val="4600"/>
-              </a:lnSpc>
-            </a:pPr>
-            <a:r>
-              <a:rPr lang="de-DE" sz="4400" b="1" dirty="0">
+            <a:pPr algn="l">
+              <a:lnSpc>
+                <a:spcPts val="3700"/>
+              </a:lnSpc>
+            </a:pPr>
+            <a:r>
+              <a:rPr lang="de-DE" sz="3600" b="1" dirty="0">
                 <a:solidFill>
                   <a:srgbClr val="05366C"/>
                 </a:solidFill>
-                <a:latin typeface="Arial" panose="020B0604020202020204" pitchFamily="34" charset="0"/>
-                <a:cs typeface="Arial" panose="020B0604020202020204" pitchFamily="34" charset="0"/>
-              </a:rPr>
-              <a:t xml:space="preserve">Wer hat die Kontrolle?</a:t>
+                <a:latin typeface="Arial"/>
+                <a:cs typeface="Arial"/>
+              </a:rPr>
+              <a:t xml:space="preserve">So spielst du</a:t>
             </a:r>
           </a:p>
         </p:txBody>
       </p:sp>
       <p:sp>
         <p:nvSpPr>
-          <p:cNvPr id="24" name="Rounded Rectangle 23"/>
+          <p:cNvPr id="24" name="Oval 23"/>
           <p:cNvSpPr/>
           <p:nvPr/>
         </p:nvSpPr>
         <p:spPr>
           <a:xfrm>
-            <a:off x="10972800" y="12527280"/>
-            <a:ext cx="8778240" cy="2971800"/>
-          </a:xfrm>
-          <a:prstGeom prst="roundRect">
+            <a:off x="1417320" y="11722608"/>
+            <a:ext cx="566928" cy="566928"/>
+          </a:xfrm>
+          <a:prstGeom prst="ellipse">
             <a:avLst/>
           </a:prstGeom>
           <a:solidFill>
-            <a:srgbClr val="2E8B57"/>
+            <a:srgbClr val="1F9E78"/>
           </a:solidFill>
           <a:ln>
             <a:noFill/>
@@ -1907,93 +1509,83 @@
           </a:fontRef>
         </p:style>
         <p:txBody>
-          <a:bodyPr rtlCol="0" anchor="t" wrap="square" lIns="256032" rIns="256032" tIns="256032" bIns="256032"/>
+          <a:bodyPr rtlCol="0" anchor="ctr" lIns="0" rIns="0" tIns="0" bIns="0"/>
           <a:lstStyle/>
           <a:p>
-            <a:pPr>
-              <a:lnSpc>
-                <a:spcPts val="3600"/>
-              </a:lnSpc>
-              <a:spcAft>
-                <a:spcPts val="400"/>
-              </a:spcAft>
-            </a:pPr>
-            <a:r>
-              <a:rPr lang="de-DE" sz="3400" b="1" dirty="0">
+            <a:pPr algn="ctr">
+              <a:lnSpc>
+                <a:spcPts val="2800"/>
+              </a:lnSpc>
+            </a:pPr>
+            <a:r>
+              <a:rPr lang="de-DE" sz="2800" b="1" dirty="0">
                 <a:solidFill>
                   <a:srgbClr val="FFFFFF"/>
                 </a:solidFill>
-                <a:latin typeface="Arial" panose="020B0604020202020204" pitchFamily="34" charset="0"/>
-                <a:cs typeface="Arial" panose="020B0604020202020204" pitchFamily="34" charset="0"/>
-              </a:rPr>
-              <a:t xml:space="preserve">Runde 1 · Hell oder dunkel</a:t>
-            </a:r>
-          </a:p>
-          <a:p>
-            <a:pPr>
-              <a:lnSpc>
-                <a:spcPts val="2900"/>
-              </a:lnSpc>
-              <a:spcAft>
-                <a:spcPts val="400"/>
-              </a:spcAft>
-            </a:pPr>
-            <a:r>
-              <a:rPr lang="de-DE" sz="2600" dirty="0">
-                <a:solidFill>
-                  <a:srgbClr val="FFFFFF"/>
-                </a:solidFill>
-                <a:latin typeface="Arial" panose="020B0604020202020204" pitchFamily="34" charset="0"/>
-                <a:cs typeface="Arial" panose="020B0604020202020204" pitchFamily="34" charset="0"/>
-              </a:rPr>
-              <a:t xml:space="preserve">Hell = 1, dunkel = 0. Ganz einfach – du gewinnst fast immer.</a:t>
-            </a:r>
-          </a:p>
-          <a:p>
-            <a:pPr>
-              <a:lnSpc>
-                <a:spcPts val="3000"/>
-              </a:lnSpc>
-            </a:pPr>
-            <a:r>
-              <a:rPr lang="de-DE" sz="2800" b="1" dirty="0">
-                <a:solidFill>
-                  <a:srgbClr val="FFFFFF"/>
-                </a:solidFill>
-                <a:latin typeface="Arial" panose="020B0604020202020204" pitchFamily="34" charset="0"/>
-                <a:cs typeface="Arial" panose="020B0604020202020204" pitchFamily="34" charset="0"/>
-              </a:rPr>
-              <a:t xml:space="preserve">Kontrolle: hoch   </a:t>
-            </a:r>
-            <a:r>
-              <a:rPr lang="de-DE" sz="2800" dirty="0">
-                <a:solidFill>
-                  <a:srgbClr val="FFFFFF"/>
-                </a:solidFill>
-                <a:latin typeface="Arial" panose="020B0604020202020204" pitchFamily="34" charset="0"/>
-                <a:cs typeface="Arial" panose="020B0604020202020204" pitchFamily="34" charset="0"/>
-              </a:rPr>
-              <a:t xml:space="preserve">●●●●●</a:t>
+                <a:latin typeface="Arial"/>
+                <a:cs typeface="Arial"/>
+              </a:rPr>
+              <a:t xml:space="preserve">1</a:t>
             </a:r>
           </a:p>
         </p:txBody>
       </p:sp>
       <p:sp>
         <p:nvSpPr>
-          <p:cNvPr id="25" name="Rounded Rectangle 24"/>
+          <p:cNvPr id="25" name="TextBox 24"/>
+          <p:cNvSpPr txBox="1"/>
+          <p:nvPr/>
+        </p:nvSpPr>
+        <p:spPr>
+          <a:xfrm>
+            <a:off x="2240280" y="11686032"/>
+            <a:ext cx="7498079" cy="640080"/>
+          </a:xfrm>
+          <a:prstGeom prst="rect">
+            <a:avLst/>
+          </a:prstGeom>
+          <a:noFill/>
+        </p:spPr>
+        <p:txBody>
+          <a:bodyPr wrap="square" anchor="ctr" lIns="54864" rIns="54864" tIns="54864" bIns="54864">
+            <a:spAutoFit/>
+          </a:bodyPr>
+          <a:lstStyle/>
+          <a:p>
+            <a:pPr algn="l">
+              <a:lnSpc>
+                <a:spcPts val="2900"/>
+              </a:lnSpc>
+            </a:pPr>
+            <a:r>
+              <a:rPr lang="de-DE" sz="2800" dirty="0">
+                <a:solidFill>
+                  <a:srgbClr val="222222"/>
+                </a:solidFill>
+                <a:latin typeface="Arial"/>
+                <a:cs typeface="Arial"/>
+              </a:rPr>
+              <a:t xml:space="preserve">Scan den QR-Code mit dem Handy.</a:t>
+            </a:r>
+          </a:p>
+        </p:txBody>
+      </p:sp>
+      <p:sp>
+        <p:nvSpPr>
+          <p:cNvPr id="26" name="Oval 25"/>
           <p:cNvSpPr/>
           <p:nvPr/>
         </p:nvSpPr>
         <p:spPr>
           <a:xfrm>
-            <a:off x="10972800" y="15819120"/>
-            <a:ext cx="8778240" cy="2971800"/>
-          </a:xfrm>
-          <a:prstGeom prst="roundRect">
+            <a:off x="1417320" y="12490704"/>
+            <a:ext cx="566928" cy="566928"/>
+          </a:xfrm>
+          <a:prstGeom prst="ellipse">
             <a:avLst/>
           </a:prstGeom>
           <a:solidFill>
-            <a:srgbClr val="B8860B"/>
+            <a:srgbClr val="C0327A"/>
           </a:solidFill>
           <a:ln>
             <a:noFill/>
@@ -2015,93 +1607,83 @@
           </a:fontRef>
         </p:style>
         <p:txBody>
-          <a:bodyPr rtlCol="0" anchor="t" wrap="square" lIns="256032" rIns="256032" tIns="256032" bIns="256032"/>
+          <a:bodyPr rtlCol="0" anchor="ctr" lIns="0" rIns="0" tIns="0" bIns="0"/>
           <a:lstStyle/>
           <a:p>
-            <a:pPr>
-              <a:lnSpc>
-                <a:spcPts val="3600"/>
-              </a:lnSpc>
-              <a:spcAft>
-                <a:spcPts val="400"/>
-              </a:spcAft>
-            </a:pPr>
-            <a:r>
-              <a:rPr lang="de-DE" sz="3400" b="1" dirty="0">
+            <a:pPr algn="ctr">
+              <a:lnSpc>
+                <a:spcPts val="2800"/>
+              </a:lnSpc>
+            </a:pPr>
+            <a:r>
+              <a:rPr lang="de-DE" sz="2800" b="1" dirty="0">
                 <a:solidFill>
                   <a:srgbClr val="FFFFFF"/>
                 </a:solidFill>
-                <a:latin typeface="Arial" panose="020B0604020202020204" pitchFamily="34" charset="0"/>
-                <a:cs typeface="Arial" panose="020B0604020202020204" pitchFamily="34" charset="0"/>
-              </a:rPr>
-              <a:t xml:space="preserve">Runde 2 · Versteckte Regel</a:t>
-            </a:r>
-          </a:p>
-          <a:p>
-            <a:pPr>
-              <a:lnSpc>
-                <a:spcPts val="2900"/>
-              </a:lnSpc>
-              <a:spcAft>
-                <a:spcPts val="400"/>
-              </a:spcAft>
-            </a:pPr>
-            <a:r>
-              <a:rPr lang="de-DE" sz="2600" dirty="0">
-                <a:solidFill>
-                  <a:srgbClr val="FFFFFF"/>
-                </a:solidFill>
-                <a:latin typeface="Arial" panose="020B0604020202020204" pitchFamily="34" charset="0"/>
-                <a:cs typeface="Arial" panose="020B0604020202020204" pitchFamily="34" charset="0"/>
-              </a:rPr>
-              <a:t xml:space="preserve">Nur ein winziges Detail zählt. Plötzlich klappt es nicht mehr so gut.</a:t>
-            </a:r>
-          </a:p>
-          <a:p>
-            <a:pPr>
-              <a:lnSpc>
-                <a:spcPts val="3000"/>
-              </a:lnSpc>
-            </a:pPr>
-            <a:r>
-              <a:rPr lang="de-DE" sz="2800" b="1" dirty="0">
-                <a:solidFill>
-                  <a:srgbClr val="FFFFFF"/>
-                </a:solidFill>
-                <a:latin typeface="Arial" panose="020B0604020202020204" pitchFamily="34" charset="0"/>
-                <a:cs typeface="Arial" panose="020B0604020202020204" pitchFamily="34" charset="0"/>
-              </a:rPr>
-              <a:t xml:space="preserve">Kontrolle: mittel   </a:t>
-            </a:r>
-            <a:r>
-              <a:rPr lang="de-DE" sz="2800" dirty="0">
-                <a:solidFill>
-                  <a:srgbClr val="FFFFFF"/>
-                </a:solidFill>
-                <a:latin typeface="Arial" panose="020B0604020202020204" pitchFamily="34" charset="0"/>
-                <a:cs typeface="Arial" panose="020B0604020202020204" pitchFamily="34" charset="0"/>
-              </a:rPr>
-              <a:t xml:space="preserve">●●●○○</a:t>
+                <a:latin typeface="Arial"/>
+                <a:cs typeface="Arial"/>
+              </a:rPr>
+              <a:t xml:space="preserve">2</a:t>
             </a:r>
           </a:p>
         </p:txBody>
       </p:sp>
       <p:sp>
         <p:nvSpPr>
-          <p:cNvPr id="26" name="Rounded Rectangle 25"/>
+          <p:cNvPr id="27" name="TextBox 26"/>
+          <p:cNvSpPr txBox="1"/>
+          <p:nvPr/>
+        </p:nvSpPr>
+        <p:spPr>
+          <a:xfrm>
+            <a:off x="2240280" y="12454128"/>
+            <a:ext cx="7498079" cy="640080"/>
+          </a:xfrm>
+          <a:prstGeom prst="rect">
+            <a:avLst/>
+          </a:prstGeom>
+          <a:noFill/>
+        </p:spPr>
+        <p:txBody>
+          <a:bodyPr wrap="square" anchor="ctr" lIns="54864" rIns="54864" tIns="54864" bIns="54864">
+            <a:spAutoFit/>
+          </a:bodyPr>
+          <a:lstStyle/>
+          <a:p>
+            <a:pPr algn="l">
+              <a:lnSpc>
+                <a:spcPts val="2900"/>
+              </a:lnSpc>
+            </a:pPr>
+            <a:r>
+              <a:rPr lang="de-DE" sz="2800" dirty="0">
+                <a:solidFill>
+                  <a:srgbClr val="222222"/>
+                </a:solidFill>
+                <a:latin typeface="Arial"/>
+                <a:cs typeface="Arial"/>
+              </a:rPr>
+              <a:t xml:space="preserve">Wähle ein Spiel und leg los.</a:t>
+            </a:r>
+          </a:p>
+        </p:txBody>
+      </p:sp>
+      <p:sp>
+        <p:nvSpPr>
+          <p:cNvPr id="28" name="Oval 27"/>
           <p:cNvSpPr/>
           <p:nvPr/>
         </p:nvSpPr>
         <p:spPr>
           <a:xfrm>
-            <a:off x="10972800" y="19110960"/>
-            <a:ext cx="8778240" cy="2971800"/>
-          </a:xfrm>
-          <a:prstGeom prst="roundRect">
+            <a:off x="1417320" y="13258800"/>
+            <a:ext cx="566928" cy="566928"/>
+          </a:xfrm>
+          <a:prstGeom prst="ellipse">
             <a:avLst/>
           </a:prstGeom>
           <a:solidFill>
-            <a:srgbClr val="2E6FB0"/>
+            <a:srgbClr val="B8860B"/>
           </a:solidFill>
           <a:ln>
             <a:noFill/>
@@ -2123,50 +1705,1240 @@
           </a:fontRef>
         </p:style>
         <p:txBody>
-          <a:bodyPr rtlCol="0" anchor="t" wrap="square" lIns="256032" rIns="256032" tIns="256032" bIns="256032"/>
+          <a:bodyPr rtlCol="0" anchor="ctr" lIns="0" rIns="0" tIns="0" bIns="0"/>
           <a:lstStyle/>
           <a:p>
-            <a:pPr>
-              <a:lnSpc>
-                <a:spcPts val="3600"/>
+            <a:pPr algn="ctr">
+              <a:lnSpc>
+                <a:spcPts val="2800"/>
+              </a:lnSpc>
+            </a:pPr>
+            <a:r>
+              <a:rPr lang="de-DE" sz="2800" b="1" dirty="0">
+                <a:solidFill>
+                  <a:srgbClr val="FFFFFF"/>
+                </a:solidFill>
+                <a:latin typeface="Arial"/>
+                <a:cs typeface="Arial"/>
+              </a:rPr>
+              <a:t xml:space="preserve">3</a:t>
+            </a:r>
+          </a:p>
+        </p:txBody>
+      </p:sp>
+      <p:sp>
+        <p:nvSpPr>
+          <p:cNvPr id="29" name="TextBox 28"/>
+          <p:cNvSpPr txBox="1"/>
+          <p:nvPr/>
+        </p:nvSpPr>
+        <p:spPr>
+          <a:xfrm>
+            <a:off x="2240280" y="13222224"/>
+            <a:ext cx="7498079" cy="640080"/>
+          </a:xfrm>
+          <a:prstGeom prst="rect">
+            <a:avLst/>
+          </a:prstGeom>
+          <a:noFill/>
+        </p:spPr>
+        <p:txBody>
+          <a:bodyPr wrap="square" anchor="ctr" lIns="54864" rIns="54864" tIns="54864" bIns="54864">
+            <a:spAutoFit/>
+          </a:bodyPr>
+          <a:lstStyle/>
+          <a:p>
+            <a:pPr algn="l">
+              <a:lnSpc>
+                <a:spcPts val="2900"/>
+              </a:lnSpc>
+            </a:pPr>
+            <a:r>
+              <a:rPr lang="de-DE" sz="2800" dirty="0">
+                <a:solidFill>
+                  <a:srgbClr val="222222"/>
+                </a:solidFill>
+                <a:latin typeface="Arial"/>
+                <a:cs typeface="Arial"/>
+              </a:rPr>
+              <a:t xml:space="preserve">Oder spiel am Bildschirm am Stand.</a:t>
+            </a:r>
+          </a:p>
+        </p:txBody>
+      </p:sp>
+      <p:sp>
+        <p:nvSpPr>
+          <p:cNvPr id="30" name="TextBox 29"/>
+          <p:cNvSpPr txBox="1"/>
+          <p:nvPr/>
+        </p:nvSpPr>
+        <p:spPr>
+          <a:xfrm>
+            <a:off x="1280160" y="14127480"/>
+            <a:ext cx="8778240" cy="731520"/>
+          </a:xfrm>
+          <a:prstGeom prst="rect">
+            <a:avLst/>
+          </a:prstGeom>
+          <a:noFill/>
+        </p:spPr>
+        <p:txBody>
+          <a:bodyPr wrap="square" anchor="t" lIns="54864" rIns="54864" tIns="54864" bIns="54864">
+            <a:spAutoFit/>
+          </a:bodyPr>
+          <a:lstStyle/>
+          <a:p>
+            <a:pPr algn="l">
+              <a:lnSpc>
+                <a:spcPts val="3700"/>
+              </a:lnSpc>
+            </a:pPr>
+            <a:r>
+              <a:rPr lang="de-DE" sz="3600" b="1" dirty="0">
+                <a:solidFill>
+                  <a:srgbClr val="05366C"/>
+                </a:solidFill>
+                <a:latin typeface="Arial"/>
+                <a:cs typeface="Arial"/>
+              </a:rPr>
+              <a:t xml:space="preserve">Worum geht’s?</a:t>
+            </a:r>
+          </a:p>
+        </p:txBody>
+      </p:sp>
+      <p:sp>
+        <p:nvSpPr>
+          <p:cNvPr id="31" name="TextBox 30"/>
+          <p:cNvSpPr txBox="1"/>
+          <p:nvPr/>
+        </p:nvSpPr>
+        <p:spPr>
+          <a:xfrm>
+            <a:off x="1371600" y="14740128"/>
+            <a:ext cx="8686800" cy="548640"/>
+          </a:xfrm>
+          <a:prstGeom prst="rect">
+            <a:avLst/>
+          </a:prstGeom>
+          <a:noFill/>
+        </p:spPr>
+        <p:txBody>
+          <a:bodyPr wrap="square" anchor="t" lIns="54864" rIns="54864" tIns="54864" bIns="54864">
+            <a:spAutoFit/>
+          </a:bodyPr>
+          <a:lstStyle/>
+          <a:p>
+            <a:pPr algn="l">
+              <a:lnSpc>
+                <a:spcPts val="2900"/>
+              </a:lnSpc>
+            </a:pPr>
+            <a:r>
+              <a:rPr lang="de-DE" sz="2800" dirty="0">
+                <a:solidFill>
+                  <a:srgbClr val="222222"/>
+                </a:solidFill>
+                <a:latin typeface="Arial"/>
+                <a:cs typeface="Arial"/>
+              </a:rPr>
+              <a:t xml:space="preserve">Aus Licht wird ein Bit: 0 oder 1.</a:t>
+            </a:r>
+          </a:p>
+        </p:txBody>
+      </p:sp>
+      <p:sp>
+        <p:nvSpPr>
+          <p:cNvPr id="32" name="Rounded Rectangle 31"/>
+          <p:cNvSpPr/>
+          <p:nvPr/>
+        </p:nvSpPr>
+        <p:spPr>
+          <a:xfrm>
+            <a:off x="1371600" y="15453359"/>
+            <a:ext cx="8503920" cy="749808"/>
+          </a:xfrm>
+          <a:prstGeom prst="roundRect">
+            <a:avLst/>
+          </a:prstGeom>
+          <a:solidFill>
+            <a:srgbClr val="1F9E78"/>
+          </a:solidFill>
+          <a:ln>
+            <a:noFill/>
+          </a:ln>
+          <a:effectLst/>
+        </p:spPr>
+        <p:style>
+          <a:lnRef idx="1">
+            <a:schemeClr val="accent1"/>
+          </a:lnRef>
+          <a:fillRef idx="3">
+            <a:schemeClr val="accent1"/>
+          </a:fillRef>
+          <a:effectRef idx="2">
+            <a:schemeClr val="accent1"/>
+          </a:effectRef>
+          <a:fontRef idx="minor">
+            <a:schemeClr val="lt1"/>
+          </a:fontRef>
+        </p:style>
+        <p:txBody>
+          <a:bodyPr rtlCol="0" anchor="ctr" wrap="square" lIns="320040" rIns="182880" tIns="0" bIns="0"/>
+          <a:lstStyle/>
+          <a:p>
+            <a:pPr algn="l">
+              <a:lnSpc>
+                <a:spcPts val="2700"/>
+              </a:lnSpc>
+            </a:pPr>
+            <a:r>
+              <a:rPr lang="de-DE" sz="2600" b="1" dirty="0">
+                <a:solidFill>
+                  <a:srgbClr val="FFFFFF"/>
+                </a:solidFill>
+                <a:latin typeface="Arial"/>
+                <a:cs typeface="Arial"/>
+              </a:rPr>
+              <a:t xml:space="preserve">Du steuerst das Bit</a:t>
+            </a:r>
+          </a:p>
+        </p:txBody>
+      </p:sp>
+      <p:sp>
+        <p:nvSpPr>
+          <p:cNvPr id="33" name="Rounded Rectangle 32"/>
+          <p:cNvSpPr/>
+          <p:nvPr/>
+        </p:nvSpPr>
+        <p:spPr>
+          <a:xfrm>
+            <a:off x="1371600" y="16322039"/>
+            <a:ext cx="8503920" cy="749808"/>
+          </a:xfrm>
+          <a:prstGeom prst="roundRect">
+            <a:avLst/>
+          </a:prstGeom>
+          <a:solidFill>
+            <a:srgbClr val="B8860B"/>
+          </a:solidFill>
+          <a:ln>
+            <a:noFill/>
+          </a:ln>
+          <a:effectLst/>
+        </p:spPr>
+        <p:style>
+          <a:lnRef idx="1">
+            <a:schemeClr val="accent1"/>
+          </a:lnRef>
+          <a:fillRef idx="3">
+            <a:schemeClr val="accent1"/>
+          </a:fillRef>
+          <a:effectRef idx="2">
+            <a:schemeClr val="accent1"/>
+          </a:effectRef>
+          <a:fontRef idx="minor">
+            <a:schemeClr val="lt1"/>
+          </a:fontRef>
+        </p:style>
+        <p:txBody>
+          <a:bodyPr rtlCol="0" anchor="ctr" wrap="square" lIns="320040" rIns="182880" tIns="0" bIns="0"/>
+          <a:lstStyle/>
+          <a:p>
+            <a:pPr algn="l">
+              <a:lnSpc>
+                <a:spcPts val="2700"/>
+              </a:lnSpc>
+            </a:pPr>
+            <a:r>
+              <a:rPr lang="de-DE" sz="2600" b="1" dirty="0">
+                <a:solidFill>
+                  <a:srgbClr val="2a1f00"/>
+                </a:solidFill>
+                <a:latin typeface="Arial"/>
+                <a:cs typeface="Arial"/>
+              </a:rPr>
+              <a:t xml:space="preserve">Versteckte Regel – schwerer</a:t>
+            </a:r>
+          </a:p>
+        </p:txBody>
+      </p:sp>
+      <p:sp>
+        <p:nvSpPr>
+          <p:cNvPr id="34" name="Rounded Rectangle 33"/>
+          <p:cNvSpPr/>
+          <p:nvPr/>
+        </p:nvSpPr>
+        <p:spPr>
+          <a:xfrm>
+            <a:off x="1371600" y="17190719"/>
+            <a:ext cx="8503920" cy="749808"/>
+          </a:xfrm>
+          <a:prstGeom prst="roundRect">
+            <a:avLst/>
+          </a:prstGeom>
+          <a:solidFill>
+            <a:srgbClr val="2E6FB0"/>
+          </a:solidFill>
+          <a:ln>
+            <a:noFill/>
+          </a:ln>
+          <a:effectLst/>
+        </p:spPr>
+        <p:style>
+          <a:lnRef idx="1">
+            <a:schemeClr val="accent1"/>
+          </a:lnRef>
+          <a:fillRef idx="3">
+            <a:schemeClr val="accent1"/>
+          </a:fillRef>
+          <a:effectRef idx="2">
+            <a:schemeClr val="accent1"/>
+          </a:effectRef>
+          <a:fontRef idx="minor">
+            <a:schemeClr val="lt1"/>
+          </a:fontRef>
+        </p:style>
+        <p:txBody>
+          <a:bodyPr rtlCol="0" anchor="ctr" wrap="square" lIns="320040" rIns="182880" tIns="0" bIns="0"/>
+          <a:lstStyle/>
+          <a:p>
+            <a:pPr algn="l">
+              <a:lnSpc>
+                <a:spcPts val="2700"/>
+              </a:lnSpc>
+            </a:pPr>
+            <a:r>
+              <a:rPr lang="de-DE" sz="2600" b="1" dirty="0">
+                <a:solidFill>
+                  <a:srgbClr val="FFFFFF"/>
+                </a:solidFill>
+                <a:latin typeface="Arial"/>
+                <a:cs typeface="Arial"/>
+              </a:rPr>
+              <a:t xml:space="preserve">Reiner Zufall – unmöglich</a:t>
+            </a:r>
+          </a:p>
+        </p:txBody>
+      </p:sp>
+      <p:sp>
+        <p:nvSpPr>
+          <p:cNvPr id="35" name="TextBox 34"/>
+          <p:cNvSpPr txBox="1"/>
+          <p:nvPr/>
+        </p:nvSpPr>
+        <p:spPr>
+          <a:xfrm>
+            <a:off x="1371600" y="18242280"/>
+            <a:ext cx="8686800" cy="1828800"/>
+          </a:xfrm>
+          <a:prstGeom prst="rect">
+            <a:avLst/>
+          </a:prstGeom>
+          <a:noFill/>
+        </p:spPr>
+        <p:txBody>
+          <a:bodyPr wrap="square" anchor="t" lIns="54864" rIns="54864" tIns="54864" bIns="54864">
+            <a:spAutoFit/>
+          </a:bodyPr>
+          <a:lstStyle/>
+          <a:p>
+            <a:pPr algn="l">
+              <a:lnSpc>
+                <a:spcPts val="3100"/>
+              </a:lnSpc>
+            </a:pPr>
+            <a:r>
+              <a:rPr lang="de-DE" sz="2800" dirty="0">
+                <a:solidFill>
+                  <a:srgbClr val="222222"/>
+                </a:solidFill>
+                <a:latin typeface="Arial"/>
+                <a:cs typeface="Arial"/>
+              </a:rPr>
+              <a:t xml:space="preserve">Dieser Zufall ist wichtig für künstliche Intelligenz, Internet-Sicherheit und Quantentechnik – die Technik der Zukunft.</a:t>
+            </a:r>
+          </a:p>
+        </p:txBody>
+      </p:sp>
+      <p:sp>
+        <p:nvSpPr>
+          <p:cNvPr id="36" name="TextBox 35"/>
+          <p:cNvSpPr txBox="1"/>
+          <p:nvPr/>
+        </p:nvSpPr>
+        <p:spPr>
+          <a:xfrm>
+            <a:off x="1280160" y="20299680"/>
+            <a:ext cx="8778240" cy="731520"/>
+          </a:xfrm>
+          <a:prstGeom prst="rect">
+            <a:avLst/>
+          </a:prstGeom>
+          <a:noFill/>
+        </p:spPr>
+        <p:txBody>
+          <a:bodyPr wrap="square" anchor="t" lIns="54864" rIns="54864" tIns="54864" bIns="54864">
+            <a:spAutoFit/>
+          </a:bodyPr>
+          <a:lstStyle/>
+          <a:p>
+            <a:pPr algn="l">
+              <a:lnSpc>
+                <a:spcPts val="3700"/>
+              </a:lnSpc>
+            </a:pPr>
+            <a:r>
+              <a:rPr lang="de-DE" sz="3600" b="1" dirty="0">
+                <a:solidFill>
+                  <a:srgbClr val="05366C"/>
+                </a:solidFill>
+                <a:latin typeface="Arial"/>
+                <a:cs typeface="Arial"/>
+              </a:rPr>
+              <a:t xml:space="preserve">Kontakt &amp; vernetzen</a:t>
+            </a:r>
+          </a:p>
+        </p:txBody>
+      </p:sp>
+      <p:sp>
+        <p:nvSpPr>
+          <p:cNvPr id="37" name="TextBox 36"/>
+          <p:cNvSpPr txBox="1"/>
+          <p:nvPr/>
+        </p:nvSpPr>
+        <p:spPr>
+          <a:xfrm>
+            <a:off x="1371600" y="20894040"/>
+            <a:ext cx="8686800" cy="914400"/>
+          </a:xfrm>
+          <a:prstGeom prst="rect">
+            <a:avLst/>
+          </a:prstGeom>
+          <a:noFill/>
+        </p:spPr>
+        <p:txBody>
+          <a:bodyPr wrap="square" anchor="t" lIns="54864" rIns="54864" tIns="54864" bIns="54864">
+            <a:spAutoFit/>
+          </a:bodyPr>
+          <a:lstStyle/>
+          <a:p>
+            <a:pPr algn="l">
+              <a:lnSpc>
+                <a:spcPts val="2900"/>
+              </a:lnSpc>
+            </a:pPr>
+            <a:r>
+              <a:rPr lang="de-DE" sz="2700" b="1" dirty="0">
+                <a:solidFill>
+                  <a:srgbClr val="222222"/>
+                </a:solidFill>
+                <a:latin typeface="Arial"/>
+                <a:cs typeface="Arial"/>
+              </a:rPr>
+              <a:t xml:space="preserve">Pavel Sulimov &amp; Claude Lehmann</a:t>
+            </a:r>
+          </a:p>
+          <a:p>
+            <a:pPr algn="l">
+              <a:lnSpc>
+                <a:spcPts val="2500"/>
+              </a:lnSpc>
+            </a:pPr>
+            <a:r>
+              <a:rPr lang="de-DE" sz="2300" dirty="0">
+                <a:solidFill>
+                  <a:srgbClr val="555555"/>
+                </a:solidFill>
+                <a:latin typeface="Arial"/>
+                <a:cs typeface="Arial"/>
+              </a:rPr>
+              <a:t xml:space="preserve">Quantum Lab · ZHAW School of Engineering</a:t>
+            </a:r>
+          </a:p>
+        </p:txBody>
+      </p:sp>
+      <p:pic>
+        <p:nvPicPr>
+          <p:cNvPr id="38" name="Picture 37" descr="qr_pavel.png"/>
+          <p:cNvPicPr>
+            <a:picLocks noChangeAspect="1"/>
+          </p:cNvPicPr>
+          <p:nvPr/>
+        </p:nvPicPr>
+        <p:blipFill>
+          <a:blip r:embed="rId6"/>
+          <a:stretch>
+            <a:fillRect/>
+          </a:stretch>
+        </p:blipFill>
+        <p:spPr>
+          <a:xfrm>
+            <a:off x="1508760" y="22128480"/>
+            <a:ext cx="1554480" cy="1554480"/>
+          </a:xfrm>
+          <a:prstGeom prst="rect">
+            <a:avLst/>
+          </a:prstGeom>
+        </p:spPr>
+      </p:pic>
+      <p:pic>
+        <p:nvPicPr>
+          <p:cNvPr id="39" name="Picture 38" descr="qr_claude.png"/>
+          <p:cNvPicPr>
+            <a:picLocks noChangeAspect="1"/>
+          </p:cNvPicPr>
+          <p:nvPr/>
+        </p:nvPicPr>
+        <p:blipFill>
+          <a:blip r:embed="rId7"/>
+          <a:stretch>
+            <a:fillRect/>
+          </a:stretch>
+        </p:blipFill>
+        <p:spPr>
+          <a:xfrm>
+            <a:off x="3429000" y="22128480"/>
+            <a:ext cx="1554480" cy="1554480"/>
+          </a:xfrm>
+          <a:prstGeom prst="rect">
+            <a:avLst/>
+          </a:prstGeom>
+        </p:spPr>
+      </p:pic>
+      <p:sp>
+        <p:nvSpPr>
+          <p:cNvPr id="40" name="TextBox 39"/>
+          <p:cNvSpPr txBox="1"/>
+          <p:nvPr/>
+        </p:nvSpPr>
+        <p:spPr>
+          <a:xfrm>
+            <a:off x="1371600" y="23728680"/>
+            <a:ext cx="1828800" cy="457200"/>
+          </a:xfrm>
+          <a:prstGeom prst="rect">
+            <a:avLst/>
+          </a:prstGeom>
+          <a:noFill/>
+        </p:spPr>
+        <p:txBody>
+          <a:bodyPr wrap="square" anchor="t" lIns="54864" rIns="54864" tIns="54864" bIns="54864">
+            <a:spAutoFit/>
+          </a:bodyPr>
+          <a:lstStyle/>
+          <a:p>
+            <a:pPr algn="ctr">
+              <a:lnSpc>
+                <a:spcPts val="2300"/>
+              </a:lnSpc>
+            </a:pPr>
+            <a:r>
+              <a:rPr lang="de-DE" sz="2200" b="1" dirty="0">
+                <a:solidFill>
+                  <a:srgbClr val="05366C"/>
+                </a:solidFill>
+                <a:latin typeface="Arial"/>
+                <a:cs typeface="Arial"/>
+              </a:rPr>
+              <a:t xml:space="preserve">Pavel</a:t>
+            </a:r>
+          </a:p>
+        </p:txBody>
+      </p:sp>
+      <p:sp>
+        <p:nvSpPr>
+          <p:cNvPr id="41" name="TextBox 40"/>
+          <p:cNvSpPr txBox="1"/>
+          <p:nvPr/>
+        </p:nvSpPr>
+        <p:spPr>
+          <a:xfrm>
+            <a:off x="3291840" y="23728680"/>
+            <a:ext cx="1828800" cy="457200"/>
+          </a:xfrm>
+          <a:prstGeom prst="rect">
+            <a:avLst/>
+          </a:prstGeom>
+          <a:noFill/>
+        </p:spPr>
+        <p:txBody>
+          <a:bodyPr wrap="square" anchor="t" lIns="54864" rIns="54864" tIns="54864" bIns="54864">
+            <a:spAutoFit/>
+          </a:bodyPr>
+          <a:lstStyle/>
+          <a:p>
+            <a:pPr algn="ctr">
+              <a:lnSpc>
+                <a:spcPts val="2300"/>
+              </a:lnSpc>
+            </a:pPr>
+            <a:r>
+              <a:rPr lang="de-DE" sz="2200" b="1" dirty="0">
+                <a:solidFill>
+                  <a:srgbClr val="05366C"/>
+                </a:solidFill>
+                <a:latin typeface="Arial"/>
+                <a:cs typeface="Arial"/>
+              </a:rPr>
+              <a:t xml:space="preserve">Claude</a:t>
+            </a:r>
+          </a:p>
+        </p:txBody>
+      </p:sp>
+      <p:sp>
+        <p:nvSpPr>
+          <p:cNvPr id="42" name="TextBox 41"/>
+          <p:cNvSpPr txBox="1"/>
+          <p:nvPr/>
+        </p:nvSpPr>
+        <p:spPr>
+          <a:xfrm>
+            <a:off x="5212080" y="22448520"/>
+            <a:ext cx="4572000" cy="1097280"/>
+          </a:xfrm>
+          <a:prstGeom prst="rect">
+            <a:avLst/>
+          </a:prstGeom>
+          <a:noFill/>
+        </p:spPr>
+        <p:txBody>
+          <a:bodyPr wrap="square" anchor="t" lIns="54864" rIns="54864" tIns="54864" bIns="54864">
+            <a:spAutoFit/>
+          </a:bodyPr>
+          <a:lstStyle/>
+          <a:p>
+            <a:pPr algn="l">
+              <a:lnSpc>
+                <a:spcPts val="2600"/>
+              </a:lnSpc>
+            </a:pPr>
+            <a:r>
+              <a:rPr lang="de-DE" sz="2400" b="1" dirty="0">
+                <a:solidFill>
+                  <a:srgbClr val="2e6fb0"/>
+                </a:solidFill>
+                <a:latin typeface="Arial"/>
+                <a:cs typeface="Arial"/>
+              </a:rPr>
+              <a:t xml:space="preserve">LinkedIn –</a:t>
+            </a:r>
+          </a:p>
+          <a:p>
+            <a:pPr algn="l">
+              <a:lnSpc>
+                <a:spcPts val="2400"/>
+              </a:lnSpc>
+            </a:pPr>
+            <a:r>
+              <a:rPr lang="de-DE" sz="2200" dirty="0">
+                <a:solidFill>
+                  <a:srgbClr val="555555"/>
+                </a:solidFill>
+                <a:latin typeface="Arial"/>
+                <a:cs typeface="Arial"/>
+              </a:rPr>
+              <a:t xml:space="preserve">vernetze dich mit uns!</a:t>
+            </a:r>
+          </a:p>
+        </p:txBody>
+      </p:sp>
+      <p:sp>
+        <p:nvSpPr>
+          <p:cNvPr id="43" name="TextBox 42"/>
+          <p:cNvSpPr txBox="1"/>
+          <p:nvPr/>
+        </p:nvSpPr>
+        <p:spPr>
+          <a:xfrm>
+            <a:off x="10972800" y="11338560"/>
+            <a:ext cx="8778240" cy="822960"/>
+          </a:xfrm>
+          <a:prstGeom prst="rect">
+            <a:avLst/>
+          </a:prstGeom>
+          <a:noFill/>
+        </p:spPr>
+        <p:txBody>
+          <a:bodyPr wrap="square" anchor="t" lIns="54864" rIns="54864" tIns="54864" bIns="54864">
+            <a:spAutoFit/>
+          </a:bodyPr>
+          <a:lstStyle/>
+          <a:p>
+            <a:pPr algn="l">
+              <a:lnSpc>
+                <a:spcPts val="4400"/>
+              </a:lnSpc>
+            </a:pPr>
+            <a:r>
+              <a:rPr lang="de-DE" sz="4200" b="1" dirty="0">
+                <a:solidFill>
+                  <a:srgbClr val="05366C"/>
+                </a:solidFill>
+                <a:latin typeface="Arial"/>
+                <a:cs typeface="Arial"/>
+              </a:rPr>
+              <a:t xml:space="preserve">Unsere Spiele</a:t>
+            </a:r>
+          </a:p>
+        </p:txBody>
+      </p:sp>
+      <p:sp>
+        <p:nvSpPr>
+          <p:cNvPr id="44" name="Rounded Rectangle 43"/>
+          <p:cNvSpPr/>
+          <p:nvPr/>
+        </p:nvSpPr>
+        <p:spPr>
+          <a:xfrm>
+            <a:off x="10972800" y="12344400"/>
+            <a:ext cx="8778240" cy="1591056"/>
+          </a:xfrm>
+          <a:prstGeom prst="roundRect">
+            <a:avLst/>
+          </a:prstGeom>
+          <a:solidFill>
+            <a:srgbClr val="1F9E78"/>
+          </a:solidFill>
+          <a:ln>
+            <a:noFill/>
+          </a:ln>
+          <a:effectLst/>
+        </p:spPr>
+        <p:style>
+          <a:lnRef idx="1">
+            <a:schemeClr val="accent1"/>
+          </a:lnRef>
+          <a:fillRef idx="3">
+            <a:schemeClr val="accent1"/>
+          </a:fillRef>
+          <a:effectRef idx="2">
+            <a:schemeClr val="accent1"/>
+          </a:effectRef>
+          <a:fontRef idx="minor">
+            <a:schemeClr val="lt1"/>
+          </a:fontRef>
+        </p:style>
+        <p:txBody>
+          <a:bodyPr rtlCol="0" anchor="ctr" wrap="square" lIns="1600200" rIns="182880" tIns="146304" bIns="146304"/>
+          <a:lstStyle/>
+          <a:p>
+            <a:pPr algn="l">
+              <a:lnSpc>
+                <a:spcPts val="3200"/>
               </a:lnSpc>
               <a:spcAft>
-                <a:spcPts val="400"/>
+                <a:spcPts val="150"/>
               </a:spcAft>
             </a:pPr>
             <a:r>
-              <a:rPr lang="de-DE" sz="3400" b="1" dirty="0">
+              <a:rPr lang="de-DE" sz="3000" b="1" dirty="0">
                 <a:solidFill>
                   <a:srgbClr val="FFFFFF"/>
                 </a:solidFill>
-                <a:latin typeface="Arial" panose="020B0604020202020204" pitchFamily="34" charset="0"/>
-                <a:cs typeface="Arial" panose="020B0604020202020204" pitchFamily="34" charset="0"/>
-              </a:rPr>
-              <a:t xml:space="preserve">Runde 3 · Zufall</a:t>
-            </a:r>
-          </a:p>
-          <a:p>
-            <a:pPr>
-              <a:lnSpc>
-                <a:spcPts val="2900"/>
+                <a:latin typeface="Arial"/>
+                <a:cs typeface="Arial"/>
+              </a:rPr>
+              <a:t xml:space="preserve">Quanten-Elfmeter</a:t>
+            </a:r>
+          </a:p>
+          <a:p>
+            <a:pPr algn="l">
+              <a:lnSpc>
+                <a:spcPts val="2300"/>
+              </a:lnSpc>
+            </a:pPr>
+            <a:r>
+              <a:rPr lang="de-DE" sz="2000" dirty="0">
+                <a:solidFill>
+                  <a:srgbClr val="FFFFFF"/>
+                </a:solidFill>
+                <a:latin typeface="Arial"/>
+                <a:cs typeface="Arial"/>
+              </a:rPr>
+              <a:t xml:space="preserve">Schiess am KI-Torhüter vorbei.</a:t>
+            </a:r>
+          </a:p>
+        </p:txBody>
+      </p:sp>
+      <p:pic>
+        <p:nvPicPr>
+          <p:cNvPr id="45" name="Picture 44" descr="ic_football.png"/>
+          <p:cNvPicPr>
+            <a:picLocks noChangeAspect="1"/>
+          </p:cNvPicPr>
+          <p:nvPr/>
+        </p:nvPicPr>
+        <p:blipFill>
+          <a:blip r:embed="rId8"/>
+          <a:stretch>
+            <a:fillRect/>
+          </a:stretch>
+        </p:blipFill>
+        <p:spPr>
+          <a:xfrm>
+            <a:off x="11228832" y="12591288"/>
+            <a:ext cx="1097280" cy="1097280"/>
+          </a:xfrm>
+          <a:prstGeom prst="rect">
+            <a:avLst/>
+          </a:prstGeom>
+        </p:spPr>
+      </p:pic>
+      <p:sp>
+        <p:nvSpPr>
+          <p:cNvPr id="46" name="Rounded Rectangle 45"/>
+          <p:cNvSpPr/>
+          <p:nvPr/>
+        </p:nvSpPr>
+        <p:spPr>
+          <a:xfrm>
+            <a:off x="10972800" y="14118336"/>
+            <a:ext cx="8778240" cy="1591056"/>
+          </a:xfrm>
+          <a:prstGeom prst="roundRect">
+            <a:avLst/>
+          </a:prstGeom>
+          <a:solidFill>
+            <a:srgbClr val="C0327A"/>
+          </a:solidFill>
+          <a:ln>
+            <a:noFill/>
+          </a:ln>
+          <a:effectLst/>
+        </p:spPr>
+        <p:style>
+          <a:lnRef idx="1">
+            <a:schemeClr val="accent1"/>
+          </a:lnRef>
+          <a:fillRef idx="3">
+            <a:schemeClr val="accent1"/>
+          </a:fillRef>
+          <a:effectRef idx="2">
+            <a:schemeClr val="accent1"/>
+          </a:effectRef>
+          <a:fontRef idx="minor">
+            <a:schemeClr val="lt1"/>
+          </a:fontRef>
+        </p:style>
+        <p:txBody>
+          <a:bodyPr rtlCol="0" anchor="ctr" wrap="square" lIns="1600200" rIns="182880" tIns="146304" bIns="146304"/>
+          <a:lstStyle/>
+          <a:p>
+            <a:pPr algn="l">
+              <a:lnSpc>
+                <a:spcPts val="3200"/>
               </a:lnSpc>
               <a:spcAft>
-                <a:spcPts val="400"/>
+                <a:spcPts val="150"/>
               </a:spcAft>
             </a:pPr>
             <a:r>
-              <a:rPr lang="de-DE" sz="2600" dirty="0">
+              <a:rPr lang="de-DE" sz="3000" b="1" dirty="0">
                 <a:solidFill>
                   <a:srgbClr val="FFFFFF"/>
                 </a:solidFill>
-                <a:latin typeface="Arial" panose="020B0604020202020204" pitchFamily="34" charset="0"/>
-                <a:cs typeface="Arial" panose="020B0604020202020204" pitchFamily="34" charset="0"/>
-              </a:rPr>
-              <a:t xml:space="preserve">Die Maschine mischt winzige Schwankungen. Niemand kann das Ergebnis vorhersagen.</a:t>
-            </a:r>
-          </a:p>
-          <a:p>
-            <a:pPr>
+                <a:latin typeface="Arial"/>
+                <a:cs typeface="Arial"/>
+              </a:rPr>
+              <a:t xml:space="preserve">Schlag die KI</a:t>
+            </a:r>
+          </a:p>
+          <a:p>
+            <a:pPr algn="l">
+              <a:lnSpc>
+                <a:spcPts val="2300"/>
+              </a:lnSpc>
+            </a:pPr>
+            <a:r>
+              <a:rPr lang="de-DE" sz="2000" dirty="0">
+                <a:solidFill>
+                  <a:srgbClr val="FFFFFF"/>
+                </a:solidFill>
+                <a:latin typeface="Arial"/>
+                <a:cs typeface="Arial"/>
+              </a:rPr>
+              <a:t xml:space="preserve">Sei zufälliger als eine KI.</a:t>
+            </a:r>
+          </a:p>
+        </p:txBody>
+      </p:sp>
+      <p:pic>
+        <p:nvPicPr>
+          <p:cNvPr id="47" name="Picture 46" descr="ic_robot.png"/>
+          <p:cNvPicPr>
+            <a:picLocks noChangeAspect="1"/>
+          </p:cNvPicPr>
+          <p:nvPr/>
+        </p:nvPicPr>
+        <p:blipFill>
+          <a:blip r:embed="rId9"/>
+          <a:stretch>
+            <a:fillRect/>
+          </a:stretch>
+        </p:blipFill>
+        <p:spPr>
+          <a:xfrm>
+            <a:off x="11228832" y="14365224"/>
+            <a:ext cx="1097280" cy="1097280"/>
+          </a:xfrm>
+          <a:prstGeom prst="rect">
+            <a:avLst/>
+          </a:prstGeom>
+        </p:spPr>
+      </p:pic>
+      <p:sp>
+        <p:nvSpPr>
+          <p:cNvPr id="48" name="Rounded Rectangle 47"/>
+          <p:cNvSpPr/>
+          <p:nvPr/>
+        </p:nvSpPr>
+        <p:spPr>
+          <a:xfrm>
+            <a:off x="10972800" y="15892272"/>
+            <a:ext cx="8778240" cy="1591056"/>
+          </a:xfrm>
+          <a:prstGeom prst="roundRect">
+            <a:avLst/>
+          </a:prstGeom>
+          <a:solidFill>
+            <a:srgbClr val="B8860B"/>
+          </a:solidFill>
+          <a:ln>
+            <a:noFill/>
+          </a:ln>
+          <a:effectLst/>
+        </p:spPr>
+        <p:style>
+          <a:lnRef idx="1">
+            <a:schemeClr val="accent1"/>
+          </a:lnRef>
+          <a:fillRef idx="3">
+            <a:schemeClr val="accent1"/>
+          </a:fillRef>
+          <a:effectRef idx="2">
+            <a:schemeClr val="accent1"/>
+          </a:effectRef>
+          <a:fontRef idx="minor">
+            <a:schemeClr val="lt1"/>
+          </a:fontRef>
+        </p:style>
+        <p:txBody>
+          <a:bodyPr rtlCol="0" anchor="ctr" wrap="square" lIns="1600200" rIns="182880" tIns="146304" bIns="146304"/>
+          <a:lstStyle/>
+          <a:p>
+            <a:pPr algn="l">
+              <a:lnSpc>
+                <a:spcPts val="3200"/>
+              </a:lnSpc>
+              <a:spcAft>
+                <a:spcPts val="150"/>
+              </a:spcAft>
+            </a:pPr>
+            <a:r>
+              <a:rPr lang="de-DE" sz="3000" b="1" dirty="0">
+                <a:solidFill>
+                  <a:srgbClr val="2a1f00"/>
+                </a:solidFill>
+                <a:latin typeface="Arial"/>
+                <a:cs typeface="Arial"/>
+              </a:rPr>
+              <a:t xml:space="preserve">Hack the Light</a:t>
+            </a:r>
+          </a:p>
+          <a:p>
+            <a:pPr algn="l">
+              <a:lnSpc>
+                <a:spcPts val="2300"/>
+              </a:lnSpc>
+            </a:pPr>
+            <a:r>
+              <a:rPr lang="de-DE" sz="2000" dirty="0">
+                <a:solidFill>
+                  <a:srgbClr val="2a1f00"/>
+                </a:solidFill>
+                <a:latin typeface="Arial"/>
+                <a:cs typeface="Arial"/>
+              </a:rPr>
+              <a:t xml:space="preserve">Mit der Kamera aus Licht ein Bit.</a:t>
+            </a:r>
+          </a:p>
+        </p:txBody>
+      </p:sp>
+      <p:pic>
+        <p:nvPicPr>
+          <p:cNvPr id="49" name="Picture 48" descr="ic_light.png"/>
+          <p:cNvPicPr>
+            <a:picLocks noChangeAspect="1"/>
+          </p:cNvPicPr>
+          <p:nvPr/>
+        </p:nvPicPr>
+        <p:blipFill>
+          <a:blip r:embed="rId10"/>
+          <a:stretch>
+            <a:fillRect/>
+          </a:stretch>
+        </p:blipFill>
+        <p:spPr>
+          <a:xfrm>
+            <a:off x="11228832" y="16139159"/>
+            <a:ext cx="1097280" cy="1097280"/>
+          </a:xfrm>
+          <a:prstGeom prst="rect">
+            <a:avLst/>
+          </a:prstGeom>
+        </p:spPr>
+      </p:pic>
+      <p:sp>
+        <p:nvSpPr>
+          <p:cNvPr id="50" name="Rounded Rectangle 49"/>
+          <p:cNvSpPr/>
+          <p:nvPr/>
+        </p:nvSpPr>
+        <p:spPr>
+          <a:xfrm>
+            <a:off x="10972800" y="17666208"/>
+            <a:ext cx="8778240" cy="1591056"/>
+          </a:xfrm>
+          <a:prstGeom prst="roundRect">
+            <a:avLst/>
+          </a:prstGeom>
+          <a:solidFill>
+            <a:srgbClr val="7D54C9"/>
+          </a:solidFill>
+          <a:ln>
+            <a:noFill/>
+          </a:ln>
+          <a:effectLst/>
+        </p:spPr>
+        <p:style>
+          <a:lnRef idx="1">
+            <a:schemeClr val="accent1"/>
+          </a:lnRef>
+          <a:fillRef idx="3">
+            <a:schemeClr val="accent1"/>
+          </a:fillRef>
+          <a:effectRef idx="2">
+            <a:schemeClr val="accent1"/>
+          </a:effectRef>
+          <a:fontRef idx="minor">
+            <a:schemeClr val="lt1"/>
+          </a:fontRef>
+        </p:style>
+        <p:txBody>
+          <a:bodyPr rtlCol="0" anchor="ctr" wrap="square" lIns="1600200" rIns="182880" tIns="146304" bIns="146304"/>
+          <a:lstStyle/>
+          <a:p>
+            <a:pPr algn="l">
+              <a:lnSpc>
+                <a:spcPts val="3200"/>
+              </a:lnSpc>
+              <a:spcAft>
+                <a:spcPts val="150"/>
+              </a:spcAft>
+            </a:pPr>
+            <a:r>
+              <a:rPr lang="de-DE" sz="3000" b="1" dirty="0">
+                <a:solidFill>
+                  <a:srgbClr val="FFFFFF"/>
+                </a:solidFill>
+                <a:latin typeface="Arial"/>
+                <a:cs typeface="Arial"/>
+              </a:rPr>
+              <a:t xml:space="preserve">Quanten-Schach</a:t>
+            </a:r>
+          </a:p>
+          <a:p>
+            <a:pPr algn="l">
+              <a:lnSpc>
+                <a:spcPts val="2300"/>
+              </a:lnSpc>
+            </a:pPr>
+            <a:r>
+              <a:rPr lang="de-DE" sz="2000" dirty="0">
+                <a:solidFill>
+                  <a:srgbClr val="FFFFFF"/>
+                </a:solidFill>
+                <a:latin typeface="Arial"/>
+                <a:cs typeface="Arial"/>
+              </a:rPr>
+              <a:t xml:space="preserve">Figuren an zwei Orten gleichzeitig.</a:t>
+            </a:r>
+          </a:p>
+        </p:txBody>
+      </p:sp>
+      <p:pic>
+        <p:nvPicPr>
+          <p:cNvPr id="51" name="Picture 50" descr="ic_chess.png"/>
+          <p:cNvPicPr>
+            <a:picLocks noChangeAspect="1"/>
+          </p:cNvPicPr>
+          <p:nvPr/>
+        </p:nvPicPr>
+        <p:blipFill>
+          <a:blip r:embed="rId11"/>
+          <a:stretch>
+            <a:fillRect/>
+          </a:stretch>
+        </p:blipFill>
+        <p:spPr>
+          <a:xfrm>
+            <a:off x="11228832" y="17913096"/>
+            <a:ext cx="1097280" cy="1097280"/>
+          </a:xfrm>
+          <a:prstGeom prst="rect">
+            <a:avLst/>
+          </a:prstGeom>
+        </p:spPr>
+      </p:pic>
+      <p:sp>
+        <p:nvSpPr>
+          <p:cNvPr id="52" name="Rounded Rectangle 51"/>
+          <p:cNvSpPr/>
+          <p:nvPr/>
+        </p:nvSpPr>
+        <p:spPr>
+          <a:xfrm>
+            <a:off x="10972800" y="19440144"/>
+            <a:ext cx="8778240" cy="1591056"/>
+          </a:xfrm>
+          <a:prstGeom prst="roundRect">
+            <a:avLst/>
+          </a:prstGeom>
+          <a:solidFill>
+            <a:srgbClr val="2E6FB0"/>
+          </a:solidFill>
+          <a:ln>
+            <a:noFill/>
+          </a:ln>
+          <a:effectLst/>
+        </p:spPr>
+        <p:style>
+          <a:lnRef idx="1">
+            <a:schemeClr val="accent1"/>
+          </a:lnRef>
+          <a:fillRef idx="3">
+            <a:schemeClr val="accent1"/>
+          </a:fillRef>
+          <a:effectRef idx="2">
+            <a:schemeClr val="accent1"/>
+          </a:effectRef>
+          <a:fontRef idx="minor">
+            <a:schemeClr val="lt1"/>
+          </a:fontRef>
+        </p:style>
+        <p:txBody>
+          <a:bodyPr rtlCol="0" anchor="ctr" wrap="square" lIns="1600200" rIns="182880" tIns="146304" bIns="146304"/>
+          <a:lstStyle/>
+          <a:p>
+            <a:pPr algn="l">
+              <a:lnSpc>
+                <a:spcPts val="3200"/>
+              </a:lnSpc>
+              <a:spcAft>
+                <a:spcPts val="150"/>
+              </a:spcAft>
+            </a:pPr>
+            <a:r>
+              <a:rPr lang="de-DE" sz="3000" b="1" dirty="0">
+                <a:solidFill>
+                  <a:srgbClr val="FFFFFF"/>
+                </a:solidFill>
+                <a:latin typeface="Arial"/>
+                <a:cs typeface="Arial"/>
+              </a:rPr>
+              <a:t xml:space="preserve">Quanten-Tic-Tac-Toe</a:t>
+            </a:r>
+          </a:p>
+          <a:p>
+            <a:pPr algn="l">
+              <a:lnSpc>
+                <a:spcPts val="2300"/>
+              </a:lnSpc>
+            </a:pPr>
+            <a:r>
+              <a:rPr lang="de-DE" sz="2000" dirty="0">
+                <a:solidFill>
+                  <a:srgbClr val="FFFFFF"/>
+                </a:solidFill>
+                <a:latin typeface="Arial"/>
+                <a:cs typeface="Arial"/>
+              </a:rPr>
+              <a:t xml:space="preserve">Drei gewinnt – mit Überlagerung.</a:t>
+            </a:r>
+          </a:p>
+        </p:txBody>
+      </p:sp>
+      <p:pic>
+        <p:nvPicPr>
+          <p:cNvPr id="53" name="Picture 52" descr="ic_ttt.png"/>
+          <p:cNvPicPr>
+            <a:picLocks noChangeAspect="1"/>
+          </p:cNvPicPr>
+          <p:nvPr/>
+        </p:nvPicPr>
+        <p:blipFill>
+          <a:blip r:embed="rId12"/>
+          <a:stretch>
+            <a:fillRect/>
+          </a:stretch>
+        </p:blipFill>
+        <p:spPr>
+          <a:xfrm>
+            <a:off x="11228832" y="19687032"/>
+            <a:ext cx="1097280" cy="1097280"/>
+          </a:xfrm>
+          <a:prstGeom prst="rect">
+            <a:avLst/>
+          </a:prstGeom>
+        </p:spPr>
+      </p:pic>
+      <p:pic>
+        <p:nvPicPr>
+          <p:cNvPr id="54" name="Picture 53" descr="qr.png"/>
+          <p:cNvPicPr>
+            <a:picLocks noChangeAspect="1"/>
+          </p:cNvPicPr>
+          <p:nvPr/>
+        </p:nvPicPr>
+        <p:blipFill>
+          <a:blip r:embed="rId13"/>
+          <a:stretch>
+            <a:fillRect/>
+          </a:stretch>
+        </p:blipFill>
+        <p:spPr>
+          <a:xfrm>
+            <a:off x="13670280" y="21396960"/>
+            <a:ext cx="3383280" cy="3383280"/>
+          </a:xfrm>
+          <a:prstGeom prst="rect">
+            <a:avLst/>
+          </a:prstGeom>
+        </p:spPr>
+      </p:pic>
+      <p:sp>
+        <p:nvSpPr>
+          <p:cNvPr id="55" name="TextBox 54"/>
+          <p:cNvSpPr txBox="1"/>
+          <p:nvPr/>
+        </p:nvSpPr>
+        <p:spPr>
+          <a:xfrm>
+            <a:off x="10972800" y="24963120"/>
+            <a:ext cx="8778240" cy="1097280"/>
+          </a:xfrm>
+          <a:prstGeom prst="rect">
+            <a:avLst/>
+          </a:prstGeom>
+          <a:noFill/>
+        </p:spPr>
+        <p:txBody>
+          <a:bodyPr wrap="square" anchor="t" lIns="54864" rIns="54864" tIns="54864" bIns="54864">
+            <a:spAutoFit/>
+          </a:bodyPr>
+          <a:lstStyle/>
+          <a:p>
+            <a:pPr algn="ctr">
               <a:lnSpc>
                 <a:spcPts val="3000"/>
               </a:lnSpc>
@@ -2174,22 +2946,230 @@
             <a:r>
               <a:rPr lang="de-DE" sz="2800" b="1" dirty="0">
                 <a:solidFill>
-                  <a:srgbClr val="FFFFFF"/>
-                </a:solidFill>
-                <a:latin typeface="Arial" panose="020B0604020202020204" pitchFamily="34" charset="0"/>
-                <a:cs typeface="Arial" panose="020B0604020202020204" pitchFamily="34" charset="0"/>
-              </a:rPr>
-              <a:t xml:space="preserve">Kontrolle: keine   </a:t>
-            </a:r>
-            <a:r>
-              <a:rPr lang="de-DE" sz="2800" dirty="0">
-                <a:solidFill>
-                  <a:srgbClr val="FFFFFF"/>
-                </a:solidFill>
-                <a:latin typeface="Arial" panose="020B0604020202020204" pitchFamily="34" charset="0"/>
-                <a:cs typeface="Arial" panose="020B0604020202020204" pitchFamily="34" charset="0"/>
-              </a:rPr>
-              <a:t xml:space="preserve">○○○○○</a:t>
+                  <a:srgbClr val="05366C"/>
+                </a:solidFill>
+                <a:latin typeface="Arial"/>
+                <a:cs typeface="Arial"/>
+              </a:rPr>
+              <a:t xml:space="preserve">Scan &amp; spiel am Handy!</a:t>
+            </a:r>
+          </a:p>
+          <a:p>
+            <a:pPr algn="ctr">
+              <a:lnSpc>
+                <a:spcPts val="2500"/>
+              </a:lnSpc>
+            </a:pPr>
+            <a:r>
+              <a:rPr lang="de-DE" sz="2300" dirty="0">
+                <a:solidFill>
+                  <a:srgbClr val="2e6fb0"/>
+                </a:solidFill>
+                <a:latin typeface="Arial"/>
+                <a:cs typeface="Arial"/>
+              </a:rPr>
+              <a:t xml:space="preserve">arraxis.com/nachtdertechnik</a:t>
+            </a:r>
+          </a:p>
+        </p:txBody>
+      </p:sp>
+      <p:pic>
+        <p:nvPicPr>
+          <p:cNvPr id="56" name="Picture 55" descr="q_emc2.png"/>
+          <p:cNvPicPr>
+            <a:picLocks noChangeAspect="1"/>
+          </p:cNvPicPr>
+          <p:nvPr/>
+        </p:nvPicPr>
+        <p:blipFill>
+          <a:blip r:embed="rId14"/>
+          <a:stretch>
+            <a:fillRect/>
+          </a:stretch>
+        </p:blipFill>
+        <p:spPr>
+          <a:xfrm>
+            <a:off x="4823460" y="26289000"/>
+            <a:ext cx="4023360" cy="1280160"/>
+          </a:xfrm>
+          <a:prstGeom prst="rect">
+            <a:avLst/>
+          </a:prstGeom>
+        </p:spPr>
+      </p:pic>
+      <p:pic>
+        <p:nvPicPr>
+          <p:cNvPr id="57" name="Picture 56" descr="q_atom.png"/>
+          <p:cNvPicPr>
+            <a:picLocks noChangeAspect="1"/>
+          </p:cNvPicPr>
+          <p:nvPr/>
+        </p:nvPicPr>
+        <p:blipFill>
+          <a:blip r:embed="rId15"/>
+          <a:stretch>
+            <a:fillRect/>
+          </a:stretch>
+        </p:blipFill>
+        <p:spPr>
+          <a:xfrm>
+            <a:off x="9349740" y="26014680"/>
+            <a:ext cx="1828800" cy="1828800"/>
+          </a:xfrm>
+          <a:prstGeom prst="rect">
+            <a:avLst/>
+          </a:prstGeom>
+        </p:spPr>
+      </p:pic>
+      <p:pic>
+        <p:nvPicPr>
+          <p:cNvPr id="58" name="Picture 57" descr="q_bloch.png"/>
+          <p:cNvPicPr>
+            <a:picLocks noChangeAspect="1"/>
+          </p:cNvPicPr>
+          <p:nvPr/>
+        </p:nvPicPr>
+        <p:blipFill>
+          <a:blip r:embed="rId16"/>
+          <a:stretch>
+            <a:fillRect/>
+          </a:stretch>
+        </p:blipFill>
+        <p:spPr>
+          <a:xfrm>
+            <a:off x="11681460" y="26014680"/>
+            <a:ext cx="1828800" cy="1828800"/>
+          </a:xfrm>
+          <a:prstGeom prst="rect">
+            <a:avLst/>
+          </a:prstGeom>
+        </p:spPr>
+      </p:pic>
+      <p:pic>
+        <p:nvPicPr>
+          <p:cNvPr id="59" name="Picture 58" descr="q_wave.png"/>
+          <p:cNvPicPr>
+            <a:picLocks noChangeAspect="1"/>
+          </p:cNvPicPr>
+          <p:nvPr/>
+        </p:nvPicPr>
+        <p:blipFill>
+          <a:blip r:embed="rId17"/>
+          <a:stretch>
+            <a:fillRect/>
+          </a:stretch>
+        </p:blipFill>
+        <p:spPr>
+          <a:xfrm>
+            <a:off x="14013180" y="26417016"/>
+            <a:ext cx="2560320" cy="1024128"/>
+          </a:xfrm>
+          <a:prstGeom prst="rect">
+            <a:avLst/>
+          </a:prstGeom>
+        </p:spPr>
+      </p:pic>
+      <p:pic>
+        <p:nvPicPr>
+          <p:cNvPr id="60" name="Picture 59" descr="wordmark_header.png"/>
+          <p:cNvPicPr>
+            <a:picLocks noChangeAspect="1"/>
+          </p:cNvPicPr>
+          <p:nvPr/>
+        </p:nvPicPr>
+        <p:blipFill>
+          <a:blip r:embed="rId18"/>
+          <a:stretch>
+            <a:fillRect/>
+          </a:stretch>
+        </p:blipFill>
+        <p:spPr>
+          <a:xfrm>
+            <a:off x="2194560" y="28529280"/>
+            <a:ext cx="6035040" cy="945490"/>
+          </a:xfrm>
+          <a:prstGeom prst="rect">
+            <a:avLst/>
+          </a:prstGeom>
+        </p:spPr>
+      </p:pic>
+      <p:pic>
+        <p:nvPicPr>
+          <p:cNvPr id="61" name="Picture 60" descr="quantum_lab_logo.png"/>
+          <p:cNvPicPr>
+            <a:picLocks noChangeAspect="1"/>
+          </p:cNvPicPr>
+          <p:nvPr/>
+        </p:nvPicPr>
+        <p:blipFill>
+          <a:blip r:embed="rId19"/>
+          <a:stretch>
+            <a:fillRect/>
+          </a:stretch>
+        </p:blipFill>
+        <p:spPr>
+          <a:xfrm>
+            <a:off x="10972800" y="28072080"/>
+            <a:ext cx="1554480" cy="1554480"/>
+          </a:xfrm>
+          <a:prstGeom prst="rect">
+            <a:avLst/>
+          </a:prstGeom>
+        </p:spPr>
+      </p:pic>
+      <p:sp>
+        <p:nvSpPr>
+          <p:cNvPr id="62" name="TextBox 61"/>
+          <p:cNvSpPr txBox="1"/>
+          <p:nvPr/>
+        </p:nvSpPr>
+        <p:spPr>
+          <a:xfrm>
+            <a:off x="12618720" y="28346400"/>
+            <a:ext cx="6858000" cy="1005840"/>
+          </a:xfrm>
+          <a:prstGeom prst="rect">
+            <a:avLst/>
+          </a:prstGeom>
+          <a:noFill/>
+        </p:spPr>
+        <p:txBody>
+          <a:bodyPr wrap="square" anchor="t" lIns="54864" rIns="54864" tIns="54864" bIns="54864">
+            <a:spAutoFit/>
+          </a:bodyPr>
+          <a:lstStyle/>
+          <a:p>
+            <a:pPr algn="l">
+              <a:lnSpc>
+                <a:spcPts val="3100"/>
+              </a:lnSpc>
+            </a:pPr>
+            <a:r>
+              <a:rPr lang="de-DE" sz="3000" b="1" dirty="0">
+                <a:solidFill>
+                  <a:srgbClr val="05366C"/>
+                </a:solidFill>
+                <a:latin typeface="Arial"/>
+                <a:cs typeface="Arial"/>
+              </a:rPr>
+              <a:t xml:space="preserve">Quantum Lab</a:t>
+            </a:r>
+          </a:p>
+          <a:p>
+            <a:pPr algn="l">
+              <a:lnSpc>
+                <a:spcPts val="2100"/>
+              </a:lnSpc>
+            </a:pPr>
+            <a:r>
+              <a:rPr lang="de-DE" sz="2000" dirty="0">
+                <a:solidFill>
+                  <a:srgbClr val="555555"/>
+                </a:solidFill>
+                <a:latin typeface="Arial"/>
+                <a:cs typeface="Arial"/>
+              </a:rPr>
+              <a:t xml:space="preserve">ZHAW School of Engineering</a:t>
             </a:r>
           </a:p>
         </p:txBody>

</xml_diff>